<commit_message>
update claude code security text
</commit_message>
<xml_diff>
--- a/WeeklyReports/ClaudeCode/claude-code-security.pptx
+++ b/WeeklyReports/ClaudeCode/claude-code-security.pptx
@@ -1346,7 +1346,7 @@
         </p:nvSpPr>
         <p:spPr>
           <a:xfrm>
-            <a:off x="777240" y="1371600"/>
+            <a:off x="777240" y="792126"/>
             <a:ext cx="914400" cy="914400"/>
           </a:xfrm>
           <a:prstGeom prst="ellipse">
@@ -1386,7 +1386,7 @@
         </p:blipFill>
         <p:spPr>
           <a:xfrm>
-            <a:off x="1005840" y="1600200"/>
+            <a:off x="1005840" y="1020726"/>
             <a:ext cx="457200" cy="457200"/>
           </a:xfrm>
           <a:prstGeom prst="rect">
@@ -1402,7 +1402,7 @@
         </p:nvSpPr>
         <p:spPr>
           <a:xfrm>
-            <a:off x="777240" y="2514600"/>
+            <a:off x="777240" y="1935126"/>
             <a:ext cx="10058400" cy="365760"/>
           </a:xfrm>
           <a:prstGeom prst="rect">
@@ -1441,7 +1441,7 @@
         </p:nvSpPr>
         <p:spPr>
           <a:xfrm>
-            <a:off x="777240" y="2926080"/>
+            <a:off x="777240" y="2346606"/>
             <a:ext cx="10607040" cy="1554480"/>
           </a:xfrm>
           <a:prstGeom prst="rect">
@@ -1469,9 +1469,49 @@
                 <a:ea typeface="Cambria" pitchFamily="34" charset="-122"/>
                 <a:cs typeface="Cambria" pitchFamily="34" charset="-120"/>
               </a:rPr>
-              <a:t>Claude Code を安全に使うための</a:t>
-            </a:r>
-            <a:endParaRPr lang="en-US" sz="4600" dirty="0"/>
+              <a:t>Fable</a:t>
+            </a:r>
+            <a:r>
+              <a:rPr lang="ja-JP" altLang="en-US" sz="4600" b="1" dirty="0">
+                <a:solidFill>
+                  <a:srgbClr val="0D1B2A"/>
+                </a:solidFill>
+                <a:latin typeface="Cambria" pitchFamily="34" charset="0"/>
+                <a:ea typeface="Cambria" pitchFamily="34" charset="-122"/>
+                <a:cs typeface="Cambria" pitchFamily="34" charset="-120"/>
+              </a:rPr>
+              <a:t>時代の </a:t>
+            </a:r>
+            <a:r>
+              <a:rPr lang="en-US" sz="4600" b="1" dirty="0">
+                <a:solidFill>
+                  <a:srgbClr val="0D1B2A"/>
+                </a:solidFill>
+                <a:latin typeface="Cambria" pitchFamily="34" charset="0"/>
+                <a:ea typeface="Cambria" pitchFamily="34" charset="-122"/>
+                <a:cs typeface="Cambria" pitchFamily="34" charset="-120"/>
+              </a:rPr>
+              <a:t>Claude Code </a:t>
+            </a:r>
+            <a:r>
+              <a:rPr lang="en-US" sz="4600" b="1" dirty="0" err="1">
+                <a:solidFill>
+                  <a:srgbClr val="0D1B2A"/>
+                </a:solidFill>
+                <a:latin typeface="Cambria" pitchFamily="34" charset="0"/>
+                <a:ea typeface="Cambria" pitchFamily="34" charset="-122"/>
+                <a:cs typeface="Cambria" pitchFamily="34" charset="-120"/>
+              </a:rPr>
+              <a:t>を安全に</a:t>
+            </a:r>
+            <a:endParaRPr lang="en-US" sz="4600" b="1" dirty="0">
+              <a:solidFill>
+                <a:srgbClr val="0D1B2A"/>
+              </a:solidFill>
+              <a:latin typeface="Cambria" pitchFamily="34" charset="0"/>
+              <a:ea typeface="Cambria" pitchFamily="34" charset="-122"/>
+              <a:cs typeface="Cambria" pitchFamily="34" charset="-120"/>
+            </a:endParaRPr>
           </a:p>
           <a:p>
             <a:pPr marL="0" indent="0">
@@ -1481,15 +1521,52 @@
               <a:buNone/>
             </a:pPr>
             <a:r>
-              <a:rPr lang="en-US" sz="4600" b="1" dirty="0">
-                <a:solidFill>
-                  <a:srgbClr val="C2410C"/>
+              <a:rPr lang="en-US" sz="4600" b="1" dirty="0" err="1">
+                <a:solidFill>
+                  <a:srgbClr val="0D1B2A"/>
                 </a:solidFill>
                 <a:latin typeface="Cambria" pitchFamily="34" charset="0"/>
                 <a:ea typeface="Cambria" pitchFamily="34" charset="-122"/>
                 <a:cs typeface="Cambria" pitchFamily="34" charset="-120"/>
               </a:rPr>
-              <a:t>3 つの約束</a:t>
+              <a:t>使うための</a:t>
+            </a:r>
+            <a:r>
+              <a:rPr lang="en-US" sz="4600" dirty="0"/>
+              <a:t> </a:t>
+            </a:r>
+            <a:r>
+              <a:rPr lang="en-US" sz="4600" b="1" dirty="0">
+                <a:solidFill>
+                  <a:srgbClr val="C2410C"/>
+                </a:solidFill>
+                <a:latin typeface="Cambria" pitchFamily="34" charset="0"/>
+                <a:ea typeface="Cambria" pitchFamily="34" charset="-122"/>
+                <a:cs typeface="Cambria" pitchFamily="34" charset="-120"/>
+              </a:rPr>
+              <a:t>3 </a:t>
+            </a:r>
+            <a:r>
+              <a:rPr lang="en-US" sz="4600" b="1" dirty="0" err="1">
+                <a:solidFill>
+                  <a:srgbClr val="C2410C"/>
+                </a:solidFill>
+                <a:latin typeface="Cambria" pitchFamily="34" charset="0"/>
+                <a:ea typeface="Cambria" pitchFamily="34" charset="-122"/>
+                <a:cs typeface="Cambria" pitchFamily="34" charset="-120"/>
+              </a:rPr>
+              <a:t>つの約束</a:t>
+            </a:r>
+            <a:r>
+              <a:rPr lang="ja-JP" altLang="en-US" sz="4600" b="1" dirty="0">
+                <a:solidFill>
+                  <a:srgbClr val="C2410C"/>
+                </a:solidFill>
+                <a:latin typeface="Cambria" pitchFamily="34" charset="0"/>
+                <a:ea typeface="Cambria" pitchFamily="34" charset="-122"/>
+                <a:cs typeface="Cambria" pitchFamily="34" charset="-120"/>
+              </a:rPr>
+              <a:t>事</a:t>
             </a:r>
             <a:endParaRPr lang="en-US" sz="4600" dirty="0"/>
           </a:p>
@@ -1503,7 +1580,7 @@
         </p:nvSpPr>
         <p:spPr>
           <a:xfrm>
-            <a:off x="777240" y="4572000"/>
+            <a:off x="777240" y="3992526"/>
             <a:ext cx="9509760" cy="822960"/>
           </a:xfrm>
           <a:prstGeom prst="rect">
@@ -1531,7 +1608,7 @@
                 <a:ea typeface="Calibri" pitchFamily="34" charset="-122"/>
                 <a:cs typeface="Calibri" pitchFamily="34" charset="-120"/>
               </a:rPr>
-              <a:t>Claude Code はコードを読む・書く・コマンドを実行できる強力な開発エージェント</a:t>
+              <a:t>Fable 5</a:t>
             </a:r>
             <a:r>
               <a:rPr lang="ja-JP" altLang="en-US" sz="1600" dirty="0">
@@ -1542,10 +1619,10 @@
                 <a:ea typeface="Calibri" pitchFamily="34" charset="-122"/>
                 <a:cs typeface="Calibri" pitchFamily="34" charset="-120"/>
               </a:rPr>
-              <a:t>です</a:t>
-            </a:r>
-            <a:r>
-              <a:rPr lang="en-US" sz="1600" dirty="0">
+              <a:t>は、</a:t>
+            </a:r>
+            <a:r>
+              <a:rPr lang="en-US" sz="1600" dirty="0" err="1">
                 <a:solidFill>
                   <a:srgbClr val="5B6470"/>
                 </a:solidFill>
@@ -1553,8 +1630,27 @@
                 <a:ea typeface="Calibri" pitchFamily="34" charset="-122"/>
                 <a:cs typeface="Calibri" pitchFamily="34" charset="-120"/>
               </a:rPr>
-              <a:t>。</a:t>
-            </a:r>
+              <a:t>コードを読む・書く・コマンドを実行できる</a:t>
+            </a:r>
+            <a:r>
+              <a:rPr lang="ja-JP" altLang="en-US" sz="1600" dirty="0">
+                <a:solidFill>
+                  <a:srgbClr val="5B6470"/>
+                </a:solidFill>
+                <a:latin typeface="Calibri" pitchFamily="34" charset="0"/>
+                <a:ea typeface="Calibri" pitchFamily="34" charset="-122"/>
+                <a:cs typeface="Calibri" pitchFamily="34" charset="-120"/>
+              </a:rPr>
+              <a:t>力が格段に増しています。</a:t>
+            </a:r>
+            <a:endParaRPr lang="en-US" sz="1600" dirty="0">
+              <a:solidFill>
+                <a:srgbClr val="5B6470"/>
+              </a:solidFill>
+              <a:latin typeface="Calibri" pitchFamily="34" charset="0"/>
+              <a:ea typeface="Calibri" pitchFamily="34" charset="-122"/>
+              <a:cs typeface="Calibri" pitchFamily="34" charset="-120"/>
+            </a:endParaRPr>
           </a:p>
           <a:p>
             <a:pPr marL="0" indent="0">
@@ -1564,6 +1660,28 @@
               <a:buNone/>
             </a:pPr>
             <a:r>
+              <a:rPr lang="en-US" sz="1600" dirty="0" err="1">
+                <a:solidFill>
+                  <a:srgbClr val="5B6470"/>
+                </a:solidFill>
+                <a:latin typeface="Calibri" pitchFamily="34" charset="0"/>
+                <a:ea typeface="Calibri" pitchFamily="34" charset="-122"/>
+                <a:cs typeface="Calibri" pitchFamily="34" charset="-120"/>
+              </a:rPr>
+              <a:t>だからこそ「レビューする・権限を絞る・隔離環境で動かす」を守って使</a:t>
+            </a:r>
+            <a:r>
+              <a:rPr lang="ja-JP" altLang="en-US" sz="1600" dirty="0">
+                <a:solidFill>
+                  <a:srgbClr val="5B6470"/>
+                </a:solidFill>
+                <a:latin typeface="Calibri" pitchFamily="34" charset="0"/>
+                <a:ea typeface="Calibri" pitchFamily="34" charset="-122"/>
+                <a:cs typeface="Calibri" pitchFamily="34" charset="-120"/>
+              </a:rPr>
+              <a:t>う必要があります</a:t>
+            </a:r>
+            <a:r>
               <a:rPr lang="en-US" sz="1600" dirty="0">
                 <a:solidFill>
                   <a:srgbClr val="5B6470"/>
@@ -1572,7 +1690,7 @@
                 <a:ea typeface="Calibri" pitchFamily="34" charset="-122"/>
                 <a:cs typeface="Calibri" pitchFamily="34" charset="-120"/>
               </a:rPr>
-              <a:t>だからこそ「レビューする・権限を絞る・隔離環境で動かす」を守って使います。</a:t>
+              <a:t>。</a:t>
             </a:r>
             <a:endParaRPr lang="en-US" sz="1600" dirty="0"/>
           </a:p>
@@ -1586,7 +1704,7 @@
         </p:nvSpPr>
         <p:spPr>
           <a:xfrm>
-            <a:off x="777240" y="5577840"/>
+            <a:off x="777240" y="4998366"/>
             <a:ext cx="2212848" cy="457200"/>
           </a:xfrm>
           <a:prstGeom prst="roundRect">
@@ -1620,7 +1738,7 @@
         </p:nvSpPr>
         <p:spPr>
           <a:xfrm>
-            <a:off x="777240" y="5577840"/>
+            <a:off x="777240" y="4998366"/>
             <a:ext cx="2212848" cy="457200"/>
           </a:xfrm>
           <a:prstGeom prst="rect">
@@ -1659,7 +1777,7 @@
         </p:nvSpPr>
         <p:spPr>
           <a:xfrm>
-            <a:off x="3218688" y="5577840"/>
+            <a:off x="3218688" y="4998366"/>
             <a:ext cx="1920240" cy="457200"/>
           </a:xfrm>
           <a:prstGeom prst="roundRect">
@@ -1693,7 +1811,7 @@
         </p:nvSpPr>
         <p:spPr>
           <a:xfrm>
-            <a:off x="3218688" y="5577840"/>
+            <a:off x="3218688" y="4998366"/>
             <a:ext cx="1920240" cy="457200"/>
           </a:xfrm>
           <a:prstGeom prst="rect">
@@ -1732,7 +1850,7 @@
         </p:nvSpPr>
         <p:spPr>
           <a:xfrm>
-            <a:off x="5367528" y="5577840"/>
+            <a:off x="5367528" y="4998366"/>
             <a:ext cx="1627632" cy="457200"/>
           </a:xfrm>
           <a:prstGeom prst="roundRect">
@@ -1766,7 +1884,7 @@
         </p:nvSpPr>
         <p:spPr>
           <a:xfrm>
-            <a:off x="5367528" y="5577840"/>
+            <a:off x="5367528" y="4998366"/>
             <a:ext cx="1627632" cy="457200"/>
           </a:xfrm>
           <a:prstGeom prst="rect">
@@ -1822,6 +1940,28 @@
               <a:buNone/>
             </a:pPr>
             <a:r>
+              <a:rPr lang="ja-JP" altLang="en-US" sz="1000" dirty="0">
+                <a:solidFill>
+                  <a:srgbClr val="5B6470"/>
+                </a:solidFill>
+                <a:latin typeface="Calibri" pitchFamily="34" charset="0"/>
+                <a:ea typeface="Calibri" pitchFamily="34" charset="-122"/>
+                <a:cs typeface="Calibri" pitchFamily="34" charset="-120"/>
+              </a:rPr>
+              <a:t>課</a:t>
+            </a:r>
+            <a:r>
+              <a:rPr lang="en-US" sz="1000" dirty="0" err="1">
+                <a:solidFill>
+                  <a:srgbClr val="5B6470"/>
+                </a:solidFill>
+                <a:latin typeface="Calibri" pitchFamily="34" charset="0"/>
+                <a:ea typeface="Calibri" pitchFamily="34" charset="-122"/>
+                <a:cs typeface="Calibri" pitchFamily="34" charset="-120"/>
+              </a:rPr>
+              <a:t>内向け</a:t>
+            </a:r>
+            <a:r>
               <a:rPr lang="en-US" sz="1000" dirty="0">
                 <a:solidFill>
                   <a:srgbClr val="5B6470"/>
@@ -1830,7 +1970,7 @@
                 <a:ea typeface="Calibri" pitchFamily="34" charset="-122"/>
                 <a:cs typeface="Calibri" pitchFamily="34" charset="-120"/>
               </a:rPr>
-              <a:t>社内向け セキュリティ紹介</a:t>
+              <a:t> セキュリティ紹介</a:t>
             </a:r>
             <a:endParaRPr lang="en-US" sz="1000" dirty="0"/>
           </a:p>
@@ -1872,6 +2012,53 @@
               <a:t>2026</a:t>
             </a:r>
             <a:endParaRPr lang="en-US" sz="1000" dirty="0"/>
+          </a:p>
+        </p:txBody>
+      </p:sp>
+      <p:sp>
+        <p:nvSpPr>
+          <p:cNvPr id="16" name="Text 10">
+            <a:extLst>
+              <a:ext uri="{FF2B5EF4-FFF2-40B4-BE49-F238E27FC236}">
+                <a16:creationId xmlns:a16="http://schemas.microsoft.com/office/drawing/2014/main" id="{B1968B50-6649-C984-B72D-846FFC5FA5BB}"/>
+              </a:ext>
+            </a:extLst>
+          </p:cNvPr>
+          <p:cNvSpPr/>
+          <p:nvPr/>
+        </p:nvSpPr>
+        <p:spPr>
+          <a:xfrm>
+            <a:off x="795528" y="5980177"/>
+            <a:ext cx="4674870" cy="457200"/>
+          </a:xfrm>
+          <a:prstGeom prst="rect">
+            <a:avLst/>
+          </a:prstGeom>
+          <a:noFill/>
+          <a:ln/>
+        </p:spPr>
+        <p:txBody>
+          <a:bodyPr wrap="square" lIns="0" tIns="0" rIns="0" bIns="0" rtlCol="0" anchor="ctr"/>
+          <a:lstStyle/>
+          <a:p>
+            <a:pPr>
+              <a:lnSpc>
+                <a:spcPct val="105000"/>
+              </a:lnSpc>
+            </a:pPr>
+            <a:r>
+              <a:rPr lang="en-US" sz="1250" dirty="0">
+                <a:solidFill>
+                  <a:srgbClr val="0D1B2A"/>
+                </a:solidFill>
+                <a:latin typeface="Calibri" pitchFamily="34" charset="0"/>
+                <a:ea typeface="Calibri" pitchFamily="34" charset="-122"/>
+                <a:cs typeface="Calibri" pitchFamily="34" charset="-120"/>
+              </a:rPr>
+              <a:t>https://code.claude.com/docs/en/security</a:t>
+            </a:r>
+            <a:endParaRPr lang="en-US" sz="1250" dirty="0"/>
           </a:p>
         </p:txBody>
       </p:sp>
@@ -5193,7 +5380,7 @@
         </p:blipFill>
         <p:spPr>
           <a:xfrm>
-            <a:off x="978408" y="4544568"/>
+            <a:off x="978408" y="4661524"/>
             <a:ext cx="310896" cy="310896"/>
           </a:xfrm>
           <a:prstGeom prst="rect">
@@ -5209,7 +5396,7 @@
         </p:nvSpPr>
         <p:spPr>
           <a:xfrm>
-            <a:off x="1435608" y="4453128"/>
+            <a:off x="1435608" y="4421232"/>
             <a:ext cx="4069080" cy="1060704"/>
           </a:xfrm>
           <a:prstGeom prst="rect">
@@ -10553,7 +10740,7 @@
               <a:buNone/>
             </a:pPr>
             <a:r>
-              <a:rPr lang="en-US" sz="1000" dirty="0">
+              <a:rPr lang="en-US" altLang="ja-JP" sz="1000" dirty="0">
                 <a:solidFill>
                   <a:srgbClr val="5B6470"/>
                 </a:solidFill>
@@ -10561,7 +10748,18 @@
                 <a:ea typeface="Calibri" pitchFamily="34" charset="-122"/>
                 <a:cs typeface="Calibri" pitchFamily="34" charset="-120"/>
               </a:rPr>
-              <a:t>今日覚えてほしい 3 点</a:t>
+              <a:t>3</a:t>
+            </a:r>
+            <a:r>
+              <a:rPr lang="ja-JP" altLang="en-US" sz="1000" dirty="0">
+                <a:solidFill>
+                  <a:srgbClr val="5B6470"/>
+                </a:solidFill>
+                <a:latin typeface="Calibri" pitchFamily="34" charset="0"/>
+                <a:ea typeface="Calibri" pitchFamily="34" charset="-122"/>
+                <a:cs typeface="Calibri" pitchFamily="34" charset="-120"/>
+              </a:rPr>
+              <a:t>つの約束事</a:t>
             </a:r>
             <a:endParaRPr lang="en-US" sz="1000" dirty="0"/>
           </a:p>

</xml_diff>